<commit_message>
feat: integrate v1.3 React PostgreSQL testbed
</commit_message>
<xml_diff>
--- a/docs/AGENT_TOOL_STRUCTURE.pptx
+++ b/docs/AGENT_TOOL_STRUCTURE.pptx
@@ -338,7 +338,7 @@
       </p:sp>
       <p:sp>
         <p:nvSpPr>
-          <p:cNvPr id="10" name="/agent/daily-patterns"/>
+          <p:cNvPr id="10" name="/agent/async/medication-events daily_pattern"/>
           <p:cNvSpPr/>
           <p:nvPr/>
         </p:nvSpPr>
@@ -374,7 +374,18 @@
                 <a:latin typeface="Malgun Gothic"/>
                 <a:ea typeface="Malgun Gothic"/>
               </a:rPr>
-              <a:t>/agent/daily-patterns</a:t>
+              <a:t>/agent/async/medication-events</a:t>
+            </a:r>
+            <a:br/>
+            <a:r>
+              <a:rPr lang="ko-KR" sz="850" dirty="0">
+                <a:solidFill>
+                  <a:srgbClr val="222222"/>
+                </a:solidFill>
+                <a:latin typeface="Malgun Gothic"/>
+                <a:ea typeface="Malgun Gothic"/>
+              </a:rPr>
+              <a:t>daily_pattern</a:t>
             </a:r>
             <a:endParaRPr lang="ko-KR" sz="850" dirty="0">
               <a:latin typeface="Malgun Gothic"/>
@@ -385,7 +396,7 @@
       </p:sp>
       <p:sp>
         <p:nvSpPr>
-          <p:cNvPr id="11" name="/agent/missed-dose-events"/>
+          <p:cNvPr id="11" name="/agent/async/medication-events missed_dose"/>
           <p:cNvSpPr/>
           <p:nvPr/>
         </p:nvSpPr>
@@ -421,7 +432,18 @@
                 <a:latin typeface="Malgun Gothic"/>
                 <a:ea typeface="Malgun Gothic"/>
               </a:rPr>
-              <a:t>/agent/missed-dose-events</a:t>
+              <a:t>/agent/async/medication-events</a:t>
+            </a:r>
+            <a:br/>
+            <a:r>
+              <a:rPr lang="ko-KR" sz="850" dirty="0">
+                <a:solidFill>
+                  <a:srgbClr val="222222"/>
+                </a:solidFill>
+                <a:latin typeface="Malgun Gothic"/>
+                <a:ea typeface="Malgun Gothic"/>
+              </a:rPr>
+              <a:t>missed_dose</a:t>
             </a:r>
             <a:endParaRPr lang="ko-KR" sz="850" dirty="0">
               <a:latin typeface="Malgun Gothic"/>
@@ -432,7 +454,7 @@
       </p:sp>
       <p:sp>
         <p:nvSpPr>
-          <p:cNvPr id="12" name="/agent/user-reply"/>
+          <p:cNvPr id="12" name="/agent/sync/chat"/>
           <p:cNvSpPr/>
           <p:nvPr/>
         </p:nvSpPr>
@@ -468,7 +490,7 @@
                 <a:latin typeface="Malgun Gothic"/>
                 <a:ea typeface="Malgun Gothic"/>
               </a:rPr>
-              <a:t>/agent/user-reply</a:t>
+              <a:t>/agent/sync/chat</a:t>
             </a:r>
             <a:endParaRPr lang="ko-KR" sz="850" dirty="0">
               <a:latin typeface="Malgun Gothic"/>
@@ -479,54 +501,7 @@
       </p:sp>
       <p:sp>
         <p:nvSpPr>
-          <p:cNvPr id="13" name="/agent/multiturn-chat"/>
-          <p:cNvSpPr/>
-          <p:nvPr/>
-        </p:nvSpPr>
-        <p:spPr>
-          <a:xfrm>
-            <a:off x="320040" y="3611880"/>
-            <a:ext cx="1874519" cy="438912"/>
-          </a:xfrm>
-          <a:prstGeom prst="roundRect">
-            <a:avLst/>
-          </a:prstGeom>
-          <a:solidFill>
-            <a:srgbClr val="F8FAFC"/>
-          </a:solidFill>
-          <a:ln w="11430">
-            <a:solidFill>
-              <a:srgbClr val="CBD5E1"/>
-            </a:solidFill>
-          </a:ln>
-        </p:spPr>
-        <p:txBody>
-          <a:bodyPr wrap="square" anchor="mid">
-            <a:spAutoFit/>
-          </a:bodyPr>
-          <a:lstStyle/>
-          <a:p>
-            <a:pPr algn="ctr"/>
-            <a:r>
-              <a:rPr lang="ko-KR" sz="850" dirty="0">
-                <a:solidFill>
-                  <a:srgbClr val="222222"/>
-                </a:solidFill>
-                <a:latin typeface="Malgun Gothic"/>
-                <a:ea typeface="Malgun Gothic"/>
-              </a:rPr>
-              <a:t>/agent/multiturn-chat</a:t>
-            </a:r>
-            <a:endParaRPr lang="ko-KR" sz="850" dirty="0">
-              <a:latin typeface="Malgun Gothic"/>
-              <a:ea typeface="Malgun Gothic"/>
-            </a:endParaRPr>
-          </a:p>
-        </p:txBody>
-      </p:sp>
-      <p:sp>
-        <p:nvSpPr>
-          <p:cNvPr id="14" name="IngressRouter"/>
+          <p:cNvPr id="13" name="IngressRouter"/>
           <p:cNvSpPr/>
           <p:nvPr/>
         </p:nvSpPr>
@@ -582,6 +557,43 @@
           </a:p>
         </p:txBody>
       </p:sp>
+      <p:cxnSp>
+        <p:nvCxnSpPr>
+          <p:cNvPr id="14" name="Arrow 14"/>
+          <p:cNvCxnSpPr/>
+          <p:nvPr/>
+        </p:nvCxnSpPr>
+        <p:spPr>
+          <a:xfrm>
+            <a:off x="2194560" y="1362456"/>
+            <a:ext cx="320040" cy="1243584"/>
+          </a:xfrm>
+          <a:prstGeom prst="line">
+            <a:avLst/>
+          </a:prstGeom>
+          <a:ln w="12700">
+            <a:solidFill>
+              <a:srgbClr val="94A3B8"/>
+            </a:solidFill>
+            <a:tailEnd type="none"/>
+            <a:headEnd type="triangle"/>
+          </a:ln>
+        </p:spPr>
+        <p:style>
+          <a:lnRef idx="2">
+            <a:schemeClr val="accent1"/>
+          </a:lnRef>
+          <a:fillRef idx="0">
+            <a:schemeClr val="accent1"/>
+          </a:fillRef>
+          <a:effectRef idx="1">
+            <a:schemeClr val="accent1"/>
+          </a:effectRef>
+          <a:fontRef idx="minor">
+            <a:schemeClr val="tx1"/>
+          </a:fontRef>
+        </p:style>
+      </p:cxnSp>
       <p:cxnSp>
         <p:nvCxnSpPr>
           <p:cNvPr id="15" name="Arrow 15"/>
@@ -590,8 +602,8 @@
         </p:nvCxnSpPr>
         <p:spPr>
           <a:xfrm>
-            <a:off x="2194560" y="1362456"/>
-            <a:ext cx="320040" cy="1243584"/>
+            <a:off x="2194560" y="2185415"/>
+            <a:ext cx="320040" cy="420624"/>
           </a:xfrm>
           <a:prstGeom prst="line">
             <a:avLst/>
@@ -626,9 +638,621 @@
           <p:nvPr/>
         </p:nvCxnSpPr>
         <p:spPr>
-          <a:xfrm>
-            <a:off x="2194560" y="2185415"/>
-            <a:ext cx="320040" cy="420624"/>
+          <a:xfrm flipV="1">
+            <a:off x="2194560" y="2606040"/>
+            <a:ext cx="320040" cy="402335"/>
+          </a:xfrm>
+          <a:prstGeom prst="line">
+            <a:avLst/>
+          </a:prstGeom>
+          <a:ln w="12700">
+            <a:solidFill>
+              <a:srgbClr val="94A3B8"/>
+            </a:solidFill>
+            <a:tailEnd type="none"/>
+            <a:headEnd type="triangle"/>
+          </a:ln>
+        </p:spPr>
+        <p:style>
+          <a:lnRef idx="2">
+            <a:schemeClr val="accent1"/>
+          </a:lnRef>
+          <a:fillRef idx="0">
+            <a:schemeClr val="accent1"/>
+          </a:fillRef>
+          <a:effectRef idx="1">
+            <a:schemeClr val="accent1"/>
+          </a:effectRef>
+          <a:fontRef idx="minor">
+            <a:schemeClr val="tx1"/>
+          </a:fontRef>
+        </p:style>
+      </p:cxnSp>
+      <p:sp>
+        <p:nvSpPr>
+          <p:cNvPr id="17" name="DailyPattern OptimizationService"/>
+          <p:cNvSpPr/>
+          <p:nvPr/>
+        </p:nvSpPr>
+        <p:spPr>
+          <a:xfrm>
+            <a:off x="4617720" y="960120"/>
+            <a:ext cx="1874519" cy="566928"/>
+          </a:xfrm>
+          <a:prstGeom prst="roundRect">
+            <a:avLst/>
+          </a:prstGeom>
+          <a:solidFill>
+            <a:srgbClr val="FAFAFA"/>
+          </a:solidFill>
+          <a:ln w="11430">
+            <a:solidFill>
+              <a:srgbClr val="D4D4D8"/>
+            </a:solidFill>
+          </a:ln>
+        </p:spPr>
+        <p:txBody>
+          <a:bodyPr wrap="square" anchor="mid">
+            <a:spAutoFit/>
+          </a:bodyPr>
+          <a:lstStyle/>
+          <a:p>
+            <a:pPr algn="ctr"/>
+            <a:r>
+              <a:rPr lang="ko-KR" sz="900" b="1" dirty="0">
+                <a:solidFill>
+                  <a:srgbClr val="222222"/>
+                </a:solidFill>
+                <a:latin typeface="Malgun Gothic"/>
+                <a:ea typeface="Malgun Gothic"/>
+              </a:rPr>
+              <a:t>DailyPattern</a:t>
+            </a:r>
+            <a:br/>
+            <a:r>
+              <a:rPr lang="ko-KR" sz="900" b="1" dirty="0">
+                <a:solidFill>
+                  <a:srgbClr val="222222"/>
+                </a:solidFill>
+                <a:latin typeface="Malgun Gothic"/>
+                <a:ea typeface="Malgun Gothic"/>
+              </a:rPr>
+              <a:t>OptimizationService</a:t>
+            </a:r>
+            <a:endParaRPr lang="ko-KR" sz="900" dirty="0">
+              <a:latin typeface="Malgun Gothic"/>
+              <a:ea typeface="Malgun Gothic"/>
+            </a:endParaRPr>
+          </a:p>
+        </p:txBody>
+      </p:sp>
+      <p:cxnSp>
+        <p:nvCxnSpPr>
+          <p:cNvPr id="18" name="Arrow 18"/>
+          <p:cNvCxnSpPr/>
+          <p:nvPr/>
+        </p:nvCxnSpPr>
+        <p:spPr>
+          <a:xfrm flipV="1">
+            <a:off x="4114800" y="1243584"/>
+            <a:ext cx="502919" cy="1362456"/>
+          </a:xfrm>
+          <a:prstGeom prst="line">
+            <a:avLst/>
+          </a:prstGeom>
+          <a:ln w="12700">
+            <a:solidFill>
+              <a:srgbClr val="94A3B8"/>
+            </a:solidFill>
+            <a:tailEnd type="none"/>
+            <a:headEnd type="triangle"/>
+          </a:ln>
+        </p:spPr>
+        <p:style>
+          <a:lnRef idx="2">
+            <a:schemeClr val="accent1"/>
+          </a:lnRef>
+          <a:fillRef idx="0">
+            <a:schemeClr val="accent1"/>
+          </a:fillRef>
+          <a:effectRef idx="1">
+            <a:schemeClr val="accent1"/>
+          </a:effectRef>
+          <a:fontRef idx="minor">
+            <a:schemeClr val="tx1"/>
+          </a:fontRef>
+        </p:style>
+      </p:cxnSp>
+      <p:sp>
+        <p:nvSpPr>
+          <p:cNvPr id="19" name="MissedDose CoachingService"/>
+          <p:cNvSpPr/>
+          <p:nvPr/>
+        </p:nvSpPr>
+        <p:spPr>
+          <a:xfrm>
+            <a:off x="4617720" y="1874519"/>
+            <a:ext cx="1874519" cy="566928"/>
+          </a:xfrm>
+          <a:prstGeom prst="roundRect">
+            <a:avLst/>
+          </a:prstGeom>
+          <a:solidFill>
+            <a:srgbClr val="FAFAFA"/>
+          </a:solidFill>
+          <a:ln w="11430">
+            <a:solidFill>
+              <a:srgbClr val="D4D4D8"/>
+            </a:solidFill>
+          </a:ln>
+        </p:spPr>
+        <p:txBody>
+          <a:bodyPr wrap="square" anchor="mid">
+            <a:spAutoFit/>
+          </a:bodyPr>
+          <a:lstStyle/>
+          <a:p>
+            <a:pPr algn="ctr"/>
+            <a:r>
+              <a:rPr lang="ko-KR" sz="900" b="1" dirty="0">
+                <a:solidFill>
+                  <a:srgbClr val="222222"/>
+                </a:solidFill>
+                <a:latin typeface="Malgun Gothic"/>
+                <a:ea typeface="Malgun Gothic"/>
+              </a:rPr>
+              <a:t>MissedDose</a:t>
+            </a:r>
+            <a:br/>
+            <a:r>
+              <a:rPr lang="ko-KR" sz="900" b="1" dirty="0">
+                <a:solidFill>
+                  <a:srgbClr val="222222"/>
+                </a:solidFill>
+                <a:latin typeface="Malgun Gothic"/>
+                <a:ea typeface="Malgun Gothic"/>
+              </a:rPr>
+              <a:t>CoachingService</a:t>
+            </a:r>
+            <a:endParaRPr lang="ko-KR" sz="900" dirty="0">
+              <a:latin typeface="Malgun Gothic"/>
+              <a:ea typeface="Malgun Gothic"/>
+            </a:endParaRPr>
+          </a:p>
+        </p:txBody>
+      </p:sp>
+      <p:cxnSp>
+        <p:nvCxnSpPr>
+          <p:cNvPr id="20" name="Arrow 20"/>
+          <p:cNvCxnSpPr/>
+          <p:nvPr/>
+        </p:nvCxnSpPr>
+        <p:spPr>
+          <a:xfrm flipV="1">
+            <a:off x="4114800" y="2157984"/>
+            <a:ext cx="502919" cy="448056"/>
+          </a:xfrm>
+          <a:prstGeom prst="line">
+            <a:avLst/>
+          </a:prstGeom>
+          <a:ln w="12700">
+            <a:solidFill>
+              <a:srgbClr val="94A3B8"/>
+            </a:solidFill>
+            <a:tailEnd type="none"/>
+            <a:headEnd type="triangle"/>
+          </a:ln>
+        </p:spPr>
+        <p:style>
+          <a:lnRef idx="2">
+            <a:schemeClr val="accent1"/>
+          </a:lnRef>
+          <a:fillRef idx="0">
+            <a:schemeClr val="accent1"/>
+          </a:fillRef>
+          <a:effectRef idx="1">
+            <a:schemeClr val="accent1"/>
+          </a:effectRef>
+          <a:fontRef idx="minor">
+            <a:schemeClr val="tx1"/>
+          </a:fontRef>
+        </p:style>
+      </p:cxnSp>
+      <p:sp>
+        <p:nvSpPr>
+          <p:cNvPr id="21" name="SystemPolicyRequest Service"/>
+          <p:cNvSpPr/>
+          <p:nvPr/>
+        </p:nvSpPr>
+        <p:spPr>
+          <a:xfrm>
+            <a:off x="4617720" y="3246120"/>
+            <a:ext cx="1874519" cy="566928"/>
+          </a:xfrm>
+          <a:prstGeom prst="roundRect">
+            <a:avLst/>
+          </a:prstGeom>
+          <a:solidFill>
+            <a:srgbClr val="FAFAFA"/>
+          </a:solidFill>
+          <a:ln w="11430">
+            <a:solidFill>
+              <a:srgbClr val="D4D4D8"/>
+            </a:solidFill>
+          </a:ln>
+        </p:spPr>
+        <p:txBody>
+          <a:bodyPr wrap="square" anchor="mid">
+            <a:spAutoFit/>
+          </a:bodyPr>
+          <a:lstStyle/>
+          <a:p>
+            <a:pPr algn="ctr"/>
+            <a:r>
+              <a:rPr lang="ko-KR" sz="900" b="1" dirty="0">
+                <a:solidFill>
+                  <a:srgbClr val="222222"/>
+                </a:solidFill>
+                <a:latin typeface="Malgun Gothic"/>
+                <a:ea typeface="Malgun Gothic"/>
+              </a:rPr>
+              <a:t>SystemPolicyRequest</a:t>
+            </a:r>
+            <a:br/>
+            <a:r>
+              <a:rPr lang="ko-KR" sz="900" b="1" dirty="0">
+                <a:solidFill>
+                  <a:srgbClr val="222222"/>
+                </a:solidFill>
+                <a:latin typeface="Malgun Gothic"/>
+                <a:ea typeface="Malgun Gothic"/>
+              </a:rPr>
+              <a:t>Service</a:t>
+            </a:r>
+            <a:endParaRPr lang="ko-KR" sz="900" dirty="0">
+              <a:latin typeface="Malgun Gothic"/>
+              <a:ea typeface="Malgun Gothic"/>
+            </a:endParaRPr>
+          </a:p>
+        </p:txBody>
+      </p:sp>
+      <p:cxnSp>
+        <p:nvCxnSpPr>
+          <p:cNvPr id="22" name="Arrow 22"/>
+          <p:cNvCxnSpPr/>
+          <p:nvPr/>
+        </p:nvCxnSpPr>
+        <p:spPr>
+          <a:xfrm>
+            <a:off x="4114800" y="2606040"/>
+            <a:ext cx="502919" cy="923543"/>
+          </a:xfrm>
+          <a:prstGeom prst="line">
+            <a:avLst/>
+          </a:prstGeom>
+          <a:ln w="12700">
+            <a:solidFill>
+              <a:srgbClr val="94A3B8"/>
+            </a:solidFill>
+            <a:tailEnd type="none"/>
+            <a:headEnd type="triangle"/>
+          </a:ln>
+        </p:spPr>
+        <p:style>
+          <a:lnRef idx="2">
+            <a:schemeClr val="accent1"/>
+          </a:lnRef>
+          <a:fillRef idx="0">
+            <a:schemeClr val="accent1"/>
+          </a:fillRef>
+          <a:effectRef idx="1">
+            <a:schemeClr val="accent1"/>
+          </a:effectRef>
+          <a:fontRef idx="minor">
+            <a:schemeClr val="tx1"/>
+          </a:fontRef>
+        </p:style>
+      </p:cxnSp>
+      <p:sp>
+        <p:nvSpPr>
+          <p:cNvPr id="23" name="pattern_analyzer LLM"/>
+          <p:cNvSpPr/>
+          <p:nvPr/>
+        </p:nvSpPr>
+        <p:spPr>
+          <a:xfrm>
+            <a:off x="7086600" y="868680"/>
+            <a:ext cx="1600200" cy="530352"/>
+          </a:xfrm>
+          <a:prstGeom prst="roundRect">
+            <a:avLst/>
+          </a:prstGeom>
+          <a:solidFill>
+            <a:srgbClr val="FFFDF4"/>
+          </a:solidFill>
+          <a:ln w="11430">
+            <a:solidFill>
+              <a:srgbClr val="E7C874"/>
+            </a:solidFill>
+          </a:ln>
+        </p:spPr>
+        <p:txBody>
+          <a:bodyPr wrap="square" anchor="mid">
+            <a:spAutoFit/>
+          </a:bodyPr>
+          <a:lstStyle/>
+          <a:p>
+            <a:pPr algn="ctr"/>
+            <a:r>
+              <a:rPr lang="ko-KR" sz="850" b="1" dirty="0">
+                <a:solidFill>
+                  <a:srgbClr val="222222"/>
+                </a:solidFill>
+                <a:latin typeface="Malgun Gothic"/>
+                <a:ea typeface="Malgun Gothic"/>
+              </a:rPr>
+              <a:t>pattern_analyzer</a:t>
+            </a:r>
+            <a:br/>
+            <a:r>
+              <a:rPr lang="ko-KR" sz="850" b="1" dirty="0">
+                <a:solidFill>
+                  <a:srgbClr val="222222"/>
+                </a:solidFill>
+                <a:latin typeface="Malgun Gothic"/>
+                <a:ea typeface="Malgun Gothic"/>
+              </a:rPr>
+              <a:t>LLM</a:t>
+            </a:r>
+            <a:endParaRPr lang="ko-KR" sz="850" dirty="0">
+              <a:latin typeface="Malgun Gothic"/>
+              <a:ea typeface="Malgun Gothic"/>
+            </a:endParaRPr>
+          </a:p>
+        </p:txBody>
+      </p:sp>
+      <p:sp>
+        <p:nvSpPr>
+          <p:cNvPr id="24" name="policy_planner LLM"/>
+          <p:cNvSpPr/>
+          <p:nvPr/>
+        </p:nvSpPr>
+        <p:spPr>
+          <a:xfrm>
+            <a:off x="9281160" y="1097280"/>
+            <a:ext cx="1600200" cy="530352"/>
+          </a:xfrm>
+          <a:prstGeom prst="roundRect">
+            <a:avLst/>
+          </a:prstGeom>
+          <a:solidFill>
+            <a:srgbClr val="FFFDF4"/>
+          </a:solidFill>
+          <a:ln w="11430">
+            <a:solidFill>
+              <a:srgbClr val="E7C874"/>
+            </a:solidFill>
+          </a:ln>
+        </p:spPr>
+        <p:txBody>
+          <a:bodyPr wrap="square" anchor="mid">
+            <a:spAutoFit/>
+          </a:bodyPr>
+          <a:lstStyle/>
+          <a:p>
+            <a:pPr algn="ctr"/>
+            <a:r>
+              <a:rPr lang="ko-KR" sz="850" b="1" dirty="0">
+                <a:solidFill>
+                  <a:srgbClr val="222222"/>
+                </a:solidFill>
+                <a:latin typeface="Malgun Gothic"/>
+                <a:ea typeface="Malgun Gothic"/>
+              </a:rPr>
+              <a:t>policy_planner</a:t>
+            </a:r>
+            <a:br/>
+            <a:r>
+              <a:rPr lang="ko-KR" sz="850" b="1" dirty="0">
+                <a:solidFill>
+                  <a:srgbClr val="222222"/>
+                </a:solidFill>
+                <a:latin typeface="Malgun Gothic"/>
+                <a:ea typeface="Malgun Gothic"/>
+              </a:rPr>
+              <a:t>LLM</a:t>
+            </a:r>
+            <a:endParaRPr lang="ko-KR" sz="850" dirty="0">
+              <a:latin typeface="Malgun Gothic"/>
+              <a:ea typeface="Malgun Gothic"/>
+            </a:endParaRPr>
+          </a:p>
+        </p:txBody>
+      </p:sp>
+      <p:sp>
+        <p:nvSpPr>
+          <p:cNvPr id="25" name="missed_dose_coach LLM"/>
+          <p:cNvSpPr/>
+          <p:nvPr/>
+        </p:nvSpPr>
+        <p:spPr>
+          <a:xfrm>
+            <a:off x="7086600" y="1874519"/>
+            <a:ext cx="1600200" cy="530352"/>
+          </a:xfrm>
+          <a:prstGeom prst="roundRect">
+            <a:avLst/>
+          </a:prstGeom>
+          <a:solidFill>
+            <a:srgbClr val="FFFDF4"/>
+          </a:solidFill>
+          <a:ln w="11430">
+            <a:solidFill>
+              <a:srgbClr val="E7C874"/>
+            </a:solidFill>
+          </a:ln>
+        </p:spPr>
+        <p:txBody>
+          <a:bodyPr wrap="square" anchor="mid">
+            <a:spAutoFit/>
+          </a:bodyPr>
+          <a:lstStyle/>
+          <a:p>
+            <a:pPr algn="ctr"/>
+            <a:r>
+              <a:rPr lang="ko-KR" sz="850" b="1" dirty="0">
+                <a:solidFill>
+                  <a:srgbClr val="222222"/>
+                </a:solidFill>
+                <a:latin typeface="Malgun Gothic"/>
+                <a:ea typeface="Malgun Gothic"/>
+              </a:rPr>
+              <a:t>missed_dose_coach</a:t>
+            </a:r>
+            <a:br/>
+            <a:r>
+              <a:rPr lang="ko-KR" sz="850" b="1" dirty="0">
+                <a:solidFill>
+                  <a:srgbClr val="222222"/>
+                </a:solidFill>
+                <a:latin typeface="Malgun Gothic"/>
+                <a:ea typeface="Malgun Gothic"/>
+              </a:rPr>
+              <a:t>LLM</a:t>
+            </a:r>
+            <a:endParaRPr lang="ko-KR" sz="850" dirty="0">
+              <a:latin typeface="Malgun Gothic"/>
+              <a:ea typeface="Malgun Gothic"/>
+            </a:endParaRPr>
+          </a:p>
+        </p:txBody>
+      </p:sp>
+      <p:sp>
+        <p:nvSpPr>
+          <p:cNvPr id="26" name="multiturn_chat agent LLM"/>
+          <p:cNvSpPr/>
+          <p:nvPr/>
+        </p:nvSpPr>
+        <p:spPr>
+          <a:xfrm>
+            <a:off x="7086600" y="3246120"/>
+            <a:ext cx="1600200" cy="530352"/>
+          </a:xfrm>
+          <a:prstGeom prst="roundRect">
+            <a:avLst/>
+          </a:prstGeom>
+          <a:solidFill>
+            <a:srgbClr val="FFFDF4"/>
+          </a:solidFill>
+          <a:ln w="11430">
+            <a:solidFill>
+              <a:srgbClr val="E7C874"/>
+            </a:solidFill>
+          </a:ln>
+        </p:spPr>
+        <p:txBody>
+          <a:bodyPr wrap="square" anchor="mid">
+            <a:spAutoFit/>
+          </a:bodyPr>
+          <a:lstStyle/>
+          <a:p>
+            <a:pPr algn="ctr"/>
+            <a:r>
+              <a:rPr lang="ko-KR" sz="850" b="1" dirty="0">
+                <a:solidFill>
+                  <a:srgbClr val="222222"/>
+                </a:solidFill>
+                <a:latin typeface="Malgun Gothic"/>
+                <a:ea typeface="Malgun Gothic"/>
+              </a:rPr>
+              <a:t>multiturn_chat</a:t>
+            </a:r>
+            <a:br/>
+            <a:r>
+              <a:rPr lang="ko-KR" sz="850" b="1" dirty="0">
+                <a:solidFill>
+                  <a:srgbClr val="222222"/>
+                </a:solidFill>
+                <a:latin typeface="Malgun Gothic"/>
+                <a:ea typeface="Malgun Gothic"/>
+              </a:rPr>
+              <a:t>agent LLM</a:t>
+            </a:r>
+            <a:endParaRPr lang="ko-KR" sz="850" dirty="0">
+              <a:latin typeface="Malgun Gothic"/>
+              <a:ea typeface="Malgun Gothic"/>
+            </a:endParaRPr>
+          </a:p>
+        </p:txBody>
+      </p:sp>
+      <p:sp>
+        <p:nvSpPr>
+          <p:cNvPr id="27" name="policy_planner LLM"/>
+          <p:cNvSpPr/>
+          <p:nvPr/>
+        </p:nvSpPr>
+        <p:spPr>
+          <a:xfrm>
+            <a:off x="9281160" y="3611880"/>
+            <a:ext cx="1600200" cy="530352"/>
+          </a:xfrm>
+          <a:prstGeom prst="roundRect">
+            <a:avLst/>
+          </a:prstGeom>
+          <a:solidFill>
+            <a:srgbClr val="FFFDF4"/>
+          </a:solidFill>
+          <a:ln w="11430">
+            <a:solidFill>
+              <a:srgbClr val="E7C874"/>
+            </a:solidFill>
+          </a:ln>
+        </p:spPr>
+        <p:txBody>
+          <a:bodyPr wrap="square" anchor="mid">
+            <a:spAutoFit/>
+          </a:bodyPr>
+          <a:lstStyle/>
+          <a:p>
+            <a:pPr algn="ctr"/>
+            <a:r>
+              <a:rPr lang="ko-KR" sz="850" b="1" dirty="0">
+                <a:solidFill>
+                  <a:srgbClr val="222222"/>
+                </a:solidFill>
+                <a:latin typeface="Malgun Gothic"/>
+                <a:ea typeface="Malgun Gothic"/>
+              </a:rPr>
+              <a:t>policy_planner</a:t>
+            </a:r>
+            <a:br/>
+            <a:r>
+              <a:rPr lang="ko-KR" sz="850" b="1" dirty="0">
+                <a:solidFill>
+                  <a:srgbClr val="222222"/>
+                </a:solidFill>
+                <a:latin typeface="Malgun Gothic"/>
+                <a:ea typeface="Malgun Gothic"/>
+              </a:rPr>
+              <a:t>LLM</a:t>
+            </a:r>
+            <a:endParaRPr lang="ko-KR" sz="850" dirty="0">
+              <a:latin typeface="Malgun Gothic"/>
+              <a:ea typeface="Malgun Gothic"/>
+            </a:endParaRPr>
+          </a:p>
+        </p:txBody>
+      </p:sp>
+      <p:cxnSp>
+        <p:nvCxnSpPr>
+          <p:cNvPr id="28" name="Arrow 28"/>
+          <p:cNvCxnSpPr/>
+          <p:nvPr/>
+        </p:nvCxnSpPr>
+        <p:spPr>
+          <a:xfrm flipV="1">
+            <a:off x="6492240" y="1133856"/>
+            <a:ext cx="594360" cy="109728"/>
           </a:xfrm>
           <a:prstGeom prst="line">
             <a:avLst/>
@@ -658,14 +1282,14 @@
       </p:cxnSp>
       <p:cxnSp>
         <p:nvCxnSpPr>
-          <p:cNvPr id="17" name="Arrow 17"/>
+          <p:cNvPr id="29" name="Arrow 29"/>
           <p:cNvCxnSpPr/>
           <p:nvPr/>
         </p:nvCxnSpPr>
         <p:spPr>
-          <a:xfrm flipV="1">
-            <a:off x="2194560" y="2606040"/>
-            <a:ext cx="320040" cy="402335"/>
+          <a:xfrm>
+            <a:off x="8686800" y="1133856"/>
+            <a:ext cx="594360" cy="228600"/>
           </a:xfrm>
           <a:prstGeom prst="line">
             <a:avLst/>
@@ -695,779 +1319,14 @@
       </p:cxnSp>
       <p:cxnSp>
         <p:nvCxnSpPr>
-          <p:cNvPr id="18" name="Arrow 18"/>
+          <p:cNvPr id="30" name="Arrow 30"/>
           <p:cNvCxnSpPr/>
           <p:nvPr/>
         </p:nvCxnSpPr>
         <p:spPr>
           <a:xfrm flipV="1">
-            <a:off x="2194560" y="2606040"/>
-            <a:ext cx="320040" cy="1225296"/>
-          </a:xfrm>
-          <a:prstGeom prst="line">
-            <a:avLst/>
-          </a:prstGeom>
-          <a:ln w="12700">
-            <a:solidFill>
-              <a:srgbClr val="94A3B8"/>
-            </a:solidFill>
-            <a:tailEnd type="none"/>
-            <a:headEnd type="triangle"/>
-          </a:ln>
-        </p:spPr>
-        <p:style>
-          <a:lnRef idx="2">
-            <a:schemeClr val="accent1"/>
-          </a:lnRef>
-          <a:fillRef idx="0">
-            <a:schemeClr val="accent1"/>
-          </a:fillRef>
-          <a:effectRef idx="1">
-            <a:schemeClr val="accent1"/>
-          </a:effectRef>
-          <a:fontRef idx="minor">
-            <a:schemeClr val="tx1"/>
-          </a:fontRef>
-        </p:style>
-      </p:cxnSp>
-      <p:sp>
-        <p:nvSpPr>
-          <p:cNvPr id="19" name="DailyPattern OptimizationService"/>
-          <p:cNvSpPr/>
-          <p:nvPr/>
-        </p:nvSpPr>
-        <p:spPr>
-          <a:xfrm>
-            <a:off x="4617720" y="960120"/>
-            <a:ext cx="1874519" cy="566928"/>
-          </a:xfrm>
-          <a:prstGeom prst="roundRect">
-            <a:avLst/>
-          </a:prstGeom>
-          <a:solidFill>
-            <a:srgbClr val="FAFAFA"/>
-          </a:solidFill>
-          <a:ln w="11430">
-            <a:solidFill>
-              <a:srgbClr val="D4D4D8"/>
-            </a:solidFill>
-          </a:ln>
-        </p:spPr>
-        <p:txBody>
-          <a:bodyPr wrap="square" anchor="mid">
-            <a:spAutoFit/>
-          </a:bodyPr>
-          <a:lstStyle/>
-          <a:p>
-            <a:pPr algn="ctr"/>
-            <a:r>
-              <a:rPr lang="ko-KR" sz="900" b="1" dirty="0">
-                <a:solidFill>
-                  <a:srgbClr val="222222"/>
-                </a:solidFill>
-                <a:latin typeface="Malgun Gothic"/>
-                <a:ea typeface="Malgun Gothic"/>
-              </a:rPr>
-              <a:t>DailyPattern</a:t>
-            </a:r>
-            <a:br/>
-            <a:r>
-              <a:rPr lang="ko-KR" sz="900" b="1" dirty="0">
-                <a:solidFill>
-                  <a:srgbClr val="222222"/>
-                </a:solidFill>
-                <a:latin typeface="Malgun Gothic"/>
-                <a:ea typeface="Malgun Gothic"/>
-              </a:rPr>
-              <a:t>OptimizationService</a:t>
-            </a:r>
-            <a:endParaRPr lang="ko-KR" sz="900" dirty="0">
-              <a:latin typeface="Malgun Gothic"/>
-              <a:ea typeface="Malgun Gothic"/>
-            </a:endParaRPr>
-          </a:p>
-        </p:txBody>
-      </p:sp>
-      <p:cxnSp>
-        <p:nvCxnSpPr>
-          <p:cNvPr id="20" name="Arrow 20"/>
-          <p:cNvCxnSpPr/>
-          <p:nvPr/>
-        </p:nvCxnSpPr>
-        <p:spPr>
-          <a:xfrm flipV="1">
-            <a:off x="4114800" y="1243584"/>
-            <a:ext cx="502919" cy="1362456"/>
-          </a:xfrm>
-          <a:prstGeom prst="line">
-            <a:avLst/>
-          </a:prstGeom>
-          <a:ln w="12700">
-            <a:solidFill>
-              <a:srgbClr val="94A3B8"/>
-            </a:solidFill>
-            <a:tailEnd type="none"/>
-            <a:headEnd type="triangle"/>
-          </a:ln>
-        </p:spPr>
-        <p:style>
-          <a:lnRef idx="2">
-            <a:schemeClr val="accent1"/>
-          </a:lnRef>
-          <a:fillRef idx="0">
-            <a:schemeClr val="accent1"/>
-          </a:fillRef>
-          <a:effectRef idx="1">
-            <a:schemeClr val="accent1"/>
-          </a:effectRef>
-          <a:fontRef idx="minor">
-            <a:schemeClr val="tx1"/>
-          </a:fontRef>
-        </p:style>
-      </p:cxnSp>
-      <p:sp>
-        <p:nvSpPr>
-          <p:cNvPr id="21" name="MissedDose CoachingService"/>
-          <p:cNvSpPr/>
-          <p:nvPr/>
-        </p:nvSpPr>
-        <p:spPr>
-          <a:xfrm>
-            <a:off x="4617720" y="1874519"/>
-            <a:ext cx="1874519" cy="566928"/>
-          </a:xfrm>
-          <a:prstGeom prst="roundRect">
-            <a:avLst/>
-          </a:prstGeom>
-          <a:solidFill>
-            <a:srgbClr val="FAFAFA"/>
-          </a:solidFill>
-          <a:ln w="11430">
-            <a:solidFill>
-              <a:srgbClr val="D4D4D8"/>
-            </a:solidFill>
-          </a:ln>
-        </p:spPr>
-        <p:txBody>
-          <a:bodyPr wrap="square" anchor="mid">
-            <a:spAutoFit/>
-          </a:bodyPr>
-          <a:lstStyle/>
-          <a:p>
-            <a:pPr algn="ctr"/>
-            <a:r>
-              <a:rPr lang="ko-KR" sz="900" b="1" dirty="0">
-                <a:solidFill>
-                  <a:srgbClr val="222222"/>
-                </a:solidFill>
-                <a:latin typeface="Malgun Gothic"/>
-                <a:ea typeface="Malgun Gothic"/>
-              </a:rPr>
-              <a:t>MissedDose</a:t>
-            </a:r>
-            <a:br/>
-            <a:r>
-              <a:rPr lang="ko-KR" sz="900" b="1" dirty="0">
-                <a:solidFill>
-                  <a:srgbClr val="222222"/>
-                </a:solidFill>
-                <a:latin typeface="Malgun Gothic"/>
-                <a:ea typeface="Malgun Gothic"/>
-              </a:rPr>
-              <a:t>CoachingService</a:t>
-            </a:r>
-            <a:endParaRPr lang="ko-KR" sz="900" dirty="0">
-              <a:latin typeface="Malgun Gothic"/>
-              <a:ea typeface="Malgun Gothic"/>
-            </a:endParaRPr>
-          </a:p>
-        </p:txBody>
-      </p:sp>
-      <p:cxnSp>
-        <p:nvCxnSpPr>
-          <p:cNvPr id="22" name="Arrow 22"/>
-          <p:cNvCxnSpPr/>
-          <p:nvPr/>
-        </p:nvCxnSpPr>
-        <p:spPr>
-          <a:xfrm flipV="1">
-            <a:off x="4114800" y="2157984"/>
-            <a:ext cx="502919" cy="448056"/>
-          </a:xfrm>
-          <a:prstGeom prst="line">
-            <a:avLst/>
-          </a:prstGeom>
-          <a:ln w="12700">
-            <a:solidFill>
-              <a:srgbClr val="94A3B8"/>
-            </a:solidFill>
-            <a:tailEnd type="none"/>
-            <a:headEnd type="triangle"/>
-          </a:ln>
-        </p:spPr>
-        <p:style>
-          <a:lnRef idx="2">
-            <a:schemeClr val="accent1"/>
-          </a:lnRef>
-          <a:fillRef idx="0">
-            <a:schemeClr val="accent1"/>
-          </a:fillRef>
-          <a:effectRef idx="1">
-            <a:schemeClr val="accent1"/>
-          </a:effectRef>
-          <a:fontRef idx="minor">
-            <a:schemeClr val="tx1"/>
-          </a:fontRef>
-        </p:style>
-      </p:cxnSp>
-      <p:sp>
-        <p:nvSpPr>
-          <p:cNvPr id="23" name="PatientConversation Service"/>
-          <p:cNvSpPr/>
-          <p:nvPr/>
-        </p:nvSpPr>
-        <p:spPr>
-          <a:xfrm>
-            <a:off x="4617720" y="2788920"/>
-            <a:ext cx="1874519" cy="566928"/>
-          </a:xfrm>
-          <a:prstGeom prst="roundRect">
-            <a:avLst/>
-          </a:prstGeom>
-          <a:solidFill>
-            <a:srgbClr val="FAFAFA"/>
-          </a:solidFill>
-          <a:ln w="11430">
-            <a:solidFill>
-              <a:srgbClr val="D4D4D8"/>
-            </a:solidFill>
-          </a:ln>
-        </p:spPr>
-        <p:txBody>
-          <a:bodyPr wrap="square" anchor="mid">
-            <a:spAutoFit/>
-          </a:bodyPr>
-          <a:lstStyle/>
-          <a:p>
-            <a:pPr algn="ctr"/>
-            <a:r>
-              <a:rPr lang="ko-KR" sz="900" b="1" dirty="0">
-                <a:solidFill>
-                  <a:srgbClr val="222222"/>
-                </a:solidFill>
-                <a:latin typeface="Malgun Gothic"/>
-                <a:ea typeface="Malgun Gothic"/>
-              </a:rPr>
-              <a:t>PatientConversation</a:t>
-            </a:r>
-            <a:br/>
-            <a:r>
-              <a:rPr lang="ko-KR" sz="900" b="1" dirty="0">
-                <a:solidFill>
-                  <a:srgbClr val="222222"/>
-                </a:solidFill>
-                <a:latin typeface="Malgun Gothic"/>
-                <a:ea typeface="Malgun Gothic"/>
-              </a:rPr>
-              <a:t>Service</a:t>
-            </a:r>
-            <a:endParaRPr lang="ko-KR" sz="900" dirty="0">
-              <a:latin typeface="Malgun Gothic"/>
-              <a:ea typeface="Malgun Gothic"/>
-            </a:endParaRPr>
-          </a:p>
-        </p:txBody>
-      </p:sp>
-      <p:cxnSp>
-        <p:nvCxnSpPr>
-          <p:cNvPr id="24" name="Arrow 24"/>
-          <p:cNvCxnSpPr/>
-          <p:nvPr/>
-        </p:nvCxnSpPr>
-        <p:spPr>
-          <a:xfrm>
-            <a:off x="4114800" y="2606040"/>
-            <a:ext cx="502919" cy="466343"/>
-          </a:xfrm>
-          <a:prstGeom prst="line">
-            <a:avLst/>
-          </a:prstGeom>
-          <a:ln w="12700">
-            <a:solidFill>
-              <a:srgbClr val="94A3B8"/>
-            </a:solidFill>
-            <a:tailEnd type="none"/>
-            <a:headEnd type="triangle"/>
-          </a:ln>
-        </p:spPr>
-        <p:style>
-          <a:lnRef idx="2">
-            <a:schemeClr val="accent1"/>
-          </a:lnRef>
-          <a:fillRef idx="0">
-            <a:schemeClr val="accent1"/>
-          </a:fillRef>
-          <a:effectRef idx="1">
-            <a:schemeClr val="accent1"/>
-          </a:effectRef>
-          <a:fontRef idx="minor">
-            <a:schemeClr val="tx1"/>
-          </a:fontRef>
-        </p:style>
-      </p:cxnSp>
-      <p:sp>
-        <p:nvSpPr>
-          <p:cNvPr id="25" name="SystemPolicyRequest Service"/>
-          <p:cNvSpPr/>
-          <p:nvPr/>
-        </p:nvSpPr>
-        <p:spPr>
-          <a:xfrm>
-            <a:off x="4617720" y="3703320"/>
-            <a:ext cx="1874519" cy="566928"/>
-          </a:xfrm>
-          <a:prstGeom prst="roundRect">
-            <a:avLst/>
-          </a:prstGeom>
-          <a:solidFill>
-            <a:srgbClr val="FAFAFA"/>
-          </a:solidFill>
-          <a:ln w="11430">
-            <a:solidFill>
-              <a:srgbClr val="D4D4D8"/>
-            </a:solidFill>
-          </a:ln>
-        </p:spPr>
-        <p:txBody>
-          <a:bodyPr wrap="square" anchor="mid">
-            <a:spAutoFit/>
-          </a:bodyPr>
-          <a:lstStyle/>
-          <a:p>
-            <a:pPr algn="ctr"/>
-            <a:r>
-              <a:rPr lang="ko-KR" sz="900" b="1" dirty="0">
-                <a:solidFill>
-                  <a:srgbClr val="222222"/>
-                </a:solidFill>
-                <a:latin typeface="Malgun Gothic"/>
-                <a:ea typeface="Malgun Gothic"/>
-              </a:rPr>
-              <a:t>SystemPolicyRequest</a:t>
-            </a:r>
-            <a:br/>
-            <a:r>
-              <a:rPr lang="ko-KR" sz="900" b="1" dirty="0">
-                <a:solidFill>
-                  <a:srgbClr val="222222"/>
-                </a:solidFill>
-                <a:latin typeface="Malgun Gothic"/>
-                <a:ea typeface="Malgun Gothic"/>
-              </a:rPr>
-              <a:t>Service</a:t>
-            </a:r>
-            <a:endParaRPr lang="ko-KR" sz="900" dirty="0">
-              <a:latin typeface="Malgun Gothic"/>
-              <a:ea typeface="Malgun Gothic"/>
-            </a:endParaRPr>
-          </a:p>
-        </p:txBody>
-      </p:sp>
-      <p:cxnSp>
-        <p:nvCxnSpPr>
-          <p:cNvPr id="26" name="Arrow 26"/>
-          <p:cNvCxnSpPr/>
-          <p:nvPr/>
-        </p:nvCxnSpPr>
-        <p:spPr>
-          <a:xfrm>
-            <a:off x="4114800" y="2606040"/>
-            <a:ext cx="502919" cy="1380743"/>
-          </a:xfrm>
-          <a:prstGeom prst="line">
-            <a:avLst/>
-          </a:prstGeom>
-          <a:ln w="12700">
-            <a:solidFill>
-              <a:srgbClr val="94A3B8"/>
-            </a:solidFill>
-            <a:tailEnd type="none"/>
-            <a:headEnd type="triangle"/>
-          </a:ln>
-        </p:spPr>
-        <p:style>
-          <a:lnRef idx="2">
-            <a:schemeClr val="accent1"/>
-          </a:lnRef>
-          <a:fillRef idx="0">
-            <a:schemeClr val="accent1"/>
-          </a:fillRef>
-          <a:effectRef idx="1">
-            <a:schemeClr val="accent1"/>
-          </a:effectRef>
-          <a:fontRef idx="minor">
-            <a:schemeClr val="tx1"/>
-          </a:fontRef>
-        </p:style>
-      </p:cxnSp>
-      <p:sp>
-        <p:nvSpPr>
-          <p:cNvPr id="27" name="pattern_analyzer LLM"/>
-          <p:cNvSpPr/>
-          <p:nvPr/>
-        </p:nvSpPr>
-        <p:spPr>
-          <a:xfrm>
-            <a:off x="7086600" y="868680"/>
-            <a:ext cx="1600200" cy="530352"/>
-          </a:xfrm>
-          <a:prstGeom prst="roundRect">
-            <a:avLst/>
-          </a:prstGeom>
-          <a:solidFill>
-            <a:srgbClr val="FFFDF4"/>
-          </a:solidFill>
-          <a:ln w="11430">
-            <a:solidFill>
-              <a:srgbClr val="E7C874"/>
-            </a:solidFill>
-          </a:ln>
-        </p:spPr>
-        <p:txBody>
-          <a:bodyPr wrap="square" anchor="mid">
-            <a:spAutoFit/>
-          </a:bodyPr>
-          <a:lstStyle/>
-          <a:p>
-            <a:pPr algn="ctr"/>
-            <a:r>
-              <a:rPr lang="ko-KR" sz="850" b="1" dirty="0">
-                <a:solidFill>
-                  <a:srgbClr val="222222"/>
-                </a:solidFill>
-                <a:latin typeface="Malgun Gothic"/>
-                <a:ea typeface="Malgun Gothic"/>
-              </a:rPr>
-              <a:t>pattern_analyzer</a:t>
-            </a:r>
-            <a:br/>
-            <a:r>
-              <a:rPr lang="ko-KR" sz="850" b="1" dirty="0">
-                <a:solidFill>
-                  <a:srgbClr val="222222"/>
-                </a:solidFill>
-                <a:latin typeface="Malgun Gothic"/>
-                <a:ea typeface="Malgun Gothic"/>
-              </a:rPr>
-              <a:t>LLM</a:t>
-            </a:r>
-            <a:endParaRPr lang="ko-KR" sz="850" dirty="0">
-              <a:latin typeface="Malgun Gothic"/>
-              <a:ea typeface="Malgun Gothic"/>
-            </a:endParaRPr>
-          </a:p>
-        </p:txBody>
-      </p:sp>
-      <p:sp>
-        <p:nvSpPr>
-          <p:cNvPr id="28" name="policy_planner LLM"/>
-          <p:cNvSpPr/>
-          <p:nvPr/>
-        </p:nvSpPr>
-        <p:spPr>
-          <a:xfrm>
-            <a:off x="9281160" y="1097280"/>
-            <a:ext cx="1600200" cy="530352"/>
-          </a:xfrm>
-          <a:prstGeom prst="roundRect">
-            <a:avLst/>
-          </a:prstGeom>
-          <a:solidFill>
-            <a:srgbClr val="FFFDF4"/>
-          </a:solidFill>
-          <a:ln w="11430">
-            <a:solidFill>
-              <a:srgbClr val="E7C874"/>
-            </a:solidFill>
-          </a:ln>
-        </p:spPr>
-        <p:txBody>
-          <a:bodyPr wrap="square" anchor="mid">
-            <a:spAutoFit/>
-          </a:bodyPr>
-          <a:lstStyle/>
-          <a:p>
-            <a:pPr algn="ctr"/>
-            <a:r>
-              <a:rPr lang="ko-KR" sz="850" b="1" dirty="0">
-                <a:solidFill>
-                  <a:srgbClr val="222222"/>
-                </a:solidFill>
-                <a:latin typeface="Malgun Gothic"/>
-                <a:ea typeface="Malgun Gothic"/>
-              </a:rPr>
-              <a:t>policy_planner</a:t>
-            </a:r>
-            <a:br/>
-            <a:r>
-              <a:rPr lang="ko-KR" sz="850" b="1" dirty="0">
-                <a:solidFill>
-                  <a:srgbClr val="222222"/>
-                </a:solidFill>
-                <a:latin typeface="Malgun Gothic"/>
-                <a:ea typeface="Malgun Gothic"/>
-              </a:rPr>
-              <a:t>LLM</a:t>
-            </a:r>
-            <a:endParaRPr lang="ko-KR" sz="850" dirty="0">
-              <a:latin typeface="Malgun Gothic"/>
-              <a:ea typeface="Malgun Gothic"/>
-            </a:endParaRPr>
-          </a:p>
-        </p:txBody>
-      </p:sp>
-      <p:sp>
-        <p:nvSpPr>
-          <p:cNvPr id="29" name="missed_dose_coach LLM"/>
-          <p:cNvSpPr/>
-          <p:nvPr/>
-        </p:nvSpPr>
-        <p:spPr>
-          <a:xfrm>
-            <a:off x="7086600" y="1874519"/>
-            <a:ext cx="1600200" cy="530352"/>
-          </a:xfrm>
-          <a:prstGeom prst="roundRect">
-            <a:avLst/>
-          </a:prstGeom>
-          <a:solidFill>
-            <a:srgbClr val="FFFDF4"/>
-          </a:solidFill>
-          <a:ln w="11430">
-            <a:solidFill>
-              <a:srgbClr val="E7C874"/>
-            </a:solidFill>
-          </a:ln>
-        </p:spPr>
-        <p:txBody>
-          <a:bodyPr wrap="square" anchor="mid">
-            <a:spAutoFit/>
-          </a:bodyPr>
-          <a:lstStyle/>
-          <a:p>
-            <a:pPr algn="ctr"/>
-            <a:r>
-              <a:rPr lang="ko-KR" sz="850" b="1" dirty="0">
-                <a:solidFill>
-                  <a:srgbClr val="222222"/>
-                </a:solidFill>
-                <a:latin typeface="Malgun Gothic"/>
-                <a:ea typeface="Malgun Gothic"/>
-              </a:rPr>
-              <a:t>missed_dose_coach</a:t>
-            </a:r>
-            <a:br/>
-            <a:r>
-              <a:rPr lang="ko-KR" sz="850" b="1" dirty="0">
-                <a:solidFill>
-                  <a:srgbClr val="222222"/>
-                </a:solidFill>
-                <a:latin typeface="Malgun Gothic"/>
-                <a:ea typeface="Malgun Gothic"/>
-              </a:rPr>
-              <a:t>LLM</a:t>
-            </a:r>
-            <a:endParaRPr lang="ko-KR" sz="850" dirty="0">
-              <a:latin typeface="Malgun Gothic"/>
-              <a:ea typeface="Malgun Gothic"/>
-            </a:endParaRPr>
-          </a:p>
-        </p:txBody>
-      </p:sp>
-      <p:sp>
-        <p:nvSpPr>
-          <p:cNvPr id="30" name="patient_conversation agent LLM"/>
-          <p:cNvSpPr/>
-          <p:nvPr/>
-        </p:nvSpPr>
-        <p:spPr>
-          <a:xfrm>
-            <a:off x="7086600" y="2788920"/>
-            <a:ext cx="1600200" cy="530352"/>
-          </a:xfrm>
-          <a:prstGeom prst="roundRect">
-            <a:avLst/>
-          </a:prstGeom>
-          <a:solidFill>
-            <a:srgbClr val="FFFDF4"/>
-          </a:solidFill>
-          <a:ln w="11430">
-            <a:solidFill>
-              <a:srgbClr val="E7C874"/>
-            </a:solidFill>
-          </a:ln>
-        </p:spPr>
-        <p:txBody>
-          <a:bodyPr wrap="square" anchor="mid">
-            <a:spAutoFit/>
-          </a:bodyPr>
-          <a:lstStyle/>
-          <a:p>
-            <a:pPr algn="ctr"/>
-            <a:r>
-              <a:rPr lang="ko-KR" sz="850" b="1" dirty="0">
-                <a:solidFill>
-                  <a:srgbClr val="222222"/>
-                </a:solidFill>
-                <a:latin typeface="Malgun Gothic"/>
-                <a:ea typeface="Malgun Gothic"/>
-              </a:rPr>
-              <a:t>patient_conversation</a:t>
-            </a:r>
-            <a:br/>
-            <a:r>
-              <a:rPr lang="ko-KR" sz="850" b="1" dirty="0">
-                <a:solidFill>
-                  <a:srgbClr val="222222"/>
-                </a:solidFill>
-                <a:latin typeface="Malgun Gothic"/>
-                <a:ea typeface="Malgun Gothic"/>
-              </a:rPr>
-              <a:t>agent LLM</a:t>
-            </a:r>
-            <a:endParaRPr lang="ko-KR" sz="850" dirty="0">
-              <a:latin typeface="Malgun Gothic"/>
-              <a:ea typeface="Malgun Gothic"/>
-            </a:endParaRPr>
-          </a:p>
-        </p:txBody>
-      </p:sp>
-      <p:sp>
-        <p:nvSpPr>
-          <p:cNvPr id="31" name="multiturn_chat agent LLM"/>
-          <p:cNvSpPr/>
-          <p:nvPr/>
-        </p:nvSpPr>
-        <p:spPr>
-          <a:xfrm>
-            <a:off x="7086600" y="3703320"/>
-            <a:ext cx="1600200" cy="530352"/>
-          </a:xfrm>
-          <a:prstGeom prst="roundRect">
-            <a:avLst/>
-          </a:prstGeom>
-          <a:solidFill>
-            <a:srgbClr val="FFFDF4"/>
-          </a:solidFill>
-          <a:ln w="11430">
-            <a:solidFill>
-              <a:srgbClr val="E7C874"/>
-            </a:solidFill>
-          </a:ln>
-        </p:spPr>
-        <p:txBody>
-          <a:bodyPr wrap="square" anchor="mid">
-            <a:spAutoFit/>
-          </a:bodyPr>
-          <a:lstStyle/>
-          <a:p>
-            <a:pPr algn="ctr"/>
-            <a:r>
-              <a:rPr lang="ko-KR" sz="850" b="1" dirty="0">
-                <a:solidFill>
-                  <a:srgbClr val="222222"/>
-                </a:solidFill>
-                <a:latin typeface="Malgun Gothic"/>
-                <a:ea typeface="Malgun Gothic"/>
-              </a:rPr>
-              <a:t>multiturn_chat</a:t>
-            </a:r>
-            <a:br/>
-            <a:r>
-              <a:rPr lang="ko-KR" sz="850" b="1" dirty="0">
-                <a:solidFill>
-                  <a:srgbClr val="222222"/>
-                </a:solidFill>
-                <a:latin typeface="Malgun Gothic"/>
-                <a:ea typeface="Malgun Gothic"/>
-              </a:rPr>
-              <a:t>agent LLM</a:t>
-            </a:r>
-            <a:endParaRPr lang="ko-KR" sz="850" dirty="0">
-              <a:latin typeface="Malgun Gothic"/>
-              <a:ea typeface="Malgun Gothic"/>
-            </a:endParaRPr>
-          </a:p>
-        </p:txBody>
-      </p:sp>
-      <p:sp>
-        <p:nvSpPr>
-          <p:cNvPr id="32" name="policy_planner LLM"/>
-          <p:cNvSpPr/>
-          <p:nvPr/>
-        </p:nvSpPr>
-        <p:spPr>
-          <a:xfrm>
-            <a:off x="9281160" y="3886200"/>
-            <a:ext cx="1600200" cy="530352"/>
-          </a:xfrm>
-          <a:prstGeom prst="roundRect">
-            <a:avLst/>
-          </a:prstGeom>
-          <a:solidFill>
-            <a:srgbClr val="FFFDF4"/>
-          </a:solidFill>
-          <a:ln w="11430">
-            <a:solidFill>
-              <a:srgbClr val="E7C874"/>
-            </a:solidFill>
-          </a:ln>
-        </p:spPr>
-        <p:txBody>
-          <a:bodyPr wrap="square" anchor="mid">
-            <a:spAutoFit/>
-          </a:bodyPr>
-          <a:lstStyle/>
-          <a:p>
-            <a:pPr algn="ctr"/>
-            <a:r>
-              <a:rPr lang="ko-KR" sz="850" b="1" dirty="0">
-                <a:solidFill>
-                  <a:srgbClr val="222222"/>
-                </a:solidFill>
-                <a:latin typeface="Malgun Gothic"/>
-                <a:ea typeface="Malgun Gothic"/>
-              </a:rPr>
-              <a:t>policy_planner</a:t>
-            </a:r>
-            <a:br/>
-            <a:r>
-              <a:rPr lang="ko-KR" sz="850" b="1" dirty="0">
-                <a:solidFill>
-                  <a:srgbClr val="222222"/>
-                </a:solidFill>
-                <a:latin typeface="Malgun Gothic"/>
-                <a:ea typeface="Malgun Gothic"/>
-              </a:rPr>
-              <a:t>LLM</a:t>
-            </a:r>
-            <a:endParaRPr lang="ko-KR" sz="850" dirty="0">
-              <a:latin typeface="Malgun Gothic"/>
-              <a:ea typeface="Malgun Gothic"/>
-            </a:endParaRPr>
-          </a:p>
-        </p:txBody>
-      </p:sp>
-      <p:cxnSp>
-        <p:nvCxnSpPr>
-          <p:cNvPr id="33" name="Arrow 33"/>
-          <p:cNvCxnSpPr/>
-          <p:nvPr/>
-        </p:nvCxnSpPr>
-        <p:spPr>
-          <a:xfrm flipV="1">
-            <a:off x="6492240" y="1133856"/>
-            <a:ext cx="594360" cy="109728"/>
+            <a:off x="6492240" y="2139696"/>
+            <a:ext cx="594360" cy="18288"/>
           </a:xfrm>
           <a:prstGeom prst="line">
             <a:avLst/>
@@ -1497,14 +1356,14 @@
       </p:cxnSp>
       <p:cxnSp>
         <p:nvCxnSpPr>
-          <p:cNvPr id="34" name="Arrow 34"/>
+          <p:cNvPr id="31" name="Arrow 31"/>
           <p:cNvCxnSpPr/>
           <p:nvPr/>
         </p:nvCxnSpPr>
         <p:spPr>
-          <a:xfrm>
-            <a:off x="8686800" y="1133856"/>
-            <a:ext cx="594360" cy="228600"/>
+          <a:xfrm flipV="1">
+            <a:off x="6492240" y="3511296"/>
+            <a:ext cx="594360" cy="18288"/>
           </a:xfrm>
           <a:prstGeom prst="line">
             <a:avLst/>
@@ -1534,14 +1393,200 @@
       </p:cxnSp>
       <p:cxnSp>
         <p:nvCxnSpPr>
+          <p:cNvPr id="32" name="Arrow 32"/>
+          <p:cNvCxnSpPr/>
+          <p:nvPr/>
+        </p:nvCxnSpPr>
+        <p:spPr>
+          <a:xfrm>
+            <a:off x="8686800" y="3511296"/>
+            <a:ext cx="594360" cy="365760"/>
+          </a:xfrm>
+          <a:prstGeom prst="line">
+            <a:avLst/>
+          </a:prstGeom>
+          <a:ln w="12700">
+            <a:solidFill>
+              <a:srgbClr val="94A3B8"/>
+            </a:solidFill>
+            <a:tailEnd type="none"/>
+            <a:headEnd type="triangle"/>
+          </a:ln>
+        </p:spPr>
+        <p:style>
+          <a:lnRef idx="2">
+            <a:schemeClr val="accent1"/>
+          </a:lnRef>
+          <a:fillRef idx="0">
+            <a:schemeClr val="accent1"/>
+          </a:fillRef>
+          <a:effectRef idx="1">
+            <a:schemeClr val="accent1"/>
+          </a:effectRef>
+          <a:fontRef idx="minor">
+            <a:schemeClr val="tx1"/>
+          </a:fontRef>
+        </p:style>
+      </p:cxnSp>
+      <p:sp>
+        <p:nvSpPr>
+          <p:cNvPr id="33" name="PolicyIntent"/>
+          <p:cNvSpPr/>
+          <p:nvPr/>
+        </p:nvSpPr>
+        <p:spPr>
+          <a:xfrm>
+            <a:off x="7543800" y="4434840"/>
+            <a:ext cx="1783080" cy="411480"/>
+          </a:xfrm>
+          <a:prstGeom prst="roundRect">
+            <a:avLst/>
+          </a:prstGeom>
+          <a:solidFill>
+            <a:srgbClr val="F8FCF9"/>
+          </a:solidFill>
+          <a:ln w="11430">
+            <a:solidFill>
+              <a:srgbClr val="B7D5BF"/>
+            </a:solidFill>
+          </a:ln>
+        </p:spPr>
+        <p:txBody>
+          <a:bodyPr wrap="square" anchor="mid">
+            <a:spAutoFit/>
+          </a:bodyPr>
+          <a:lstStyle/>
+          <a:p>
+            <a:pPr algn="ctr"/>
+            <a:r>
+              <a:rPr lang="ko-KR" sz="760" dirty="0">
+                <a:solidFill>
+                  <a:srgbClr val="222222"/>
+                </a:solidFill>
+                <a:latin typeface="Malgun Gothic"/>
+                <a:ea typeface="Malgun Gothic"/>
+              </a:rPr>
+              <a:t>policy_change_intent</a:t>
+            </a:r>
+            <a:br/>
+            <a:r>
+              <a:rPr lang="ko-KR" sz="760" dirty="0">
+                <a:solidFill>
+                  <a:srgbClr val="222222"/>
+                </a:solidFill>
+                <a:latin typeface="Malgun Gothic"/>
+                <a:ea typeface="Malgun Gothic"/>
+              </a:rPr>
+              <a:t>구조화</a:t>
+            </a:r>
+            <a:endParaRPr lang="ko-KR" sz="760" dirty="0">
+              <a:latin typeface="Malgun Gothic"/>
+              <a:ea typeface="Malgun Gothic"/>
+            </a:endParaRPr>
+          </a:p>
+        </p:txBody>
+      </p:sp>
+      <p:sp>
+        <p:nvSpPr>
+          <p:cNvPr id="34" name="Tools"/>
+          <p:cNvSpPr/>
+          <p:nvPr/>
+        </p:nvSpPr>
+        <p:spPr>
+          <a:xfrm>
+            <a:off x="9692640" y="2057400"/>
+            <a:ext cx="1920240" cy="1234440"/>
+          </a:xfrm>
+          <a:prstGeom prst="roundRect">
+            <a:avLst/>
+          </a:prstGeom>
+          <a:solidFill>
+            <a:srgbClr val="FFF8F8"/>
+          </a:solidFill>
+          <a:ln w="11430">
+            <a:solidFill>
+              <a:srgbClr val="E0A5A5"/>
+            </a:solidFill>
+          </a:ln>
+        </p:spPr>
+        <p:txBody>
+          <a:bodyPr wrap="square" anchor="mid">
+            <a:spAutoFit/>
+          </a:bodyPr>
+          <a:lstStyle/>
+          <a:p>
+            <a:pPr algn="ctr"/>
+            <a:r>
+              <a:rPr lang="ko-KR" sz="720" b="1" dirty="0">
+                <a:solidFill>
+                  <a:srgbClr val="222222"/>
+                </a:solidFill>
+                <a:latin typeface="Malgun Gothic"/>
+                <a:ea typeface="Malgun Gothic"/>
+              </a:rPr>
+              <a:t>Tools</a:t>
+            </a:r>
+            <a:br/>
+            <a:r>
+              <a:rPr lang="ko-KR" sz="720" b="1" dirty="0">
+                <a:solidFill>
+                  <a:srgbClr val="222222"/>
+                </a:solidFill>
+                <a:latin typeface="Malgun Gothic"/>
+                <a:ea typeface="Malgun Gothic"/>
+              </a:rPr>
+              <a:t>propose_notification_policy</a:t>
+            </a:r>
+            <a:br/>
+            <a:r>
+              <a:rPr lang="ko-KR" sz="720" b="1" dirty="0">
+                <a:solidFill>
+                  <a:srgbClr val="222222"/>
+                </a:solidFill>
+                <a:latin typeface="Malgun Gothic"/>
+                <a:ea typeface="Malgun Gothic"/>
+              </a:rPr>
+              <a:t>get_pro_ctcae_questionnaire</a:t>
+            </a:r>
+            <a:br/>
+            <a:r>
+              <a:rPr lang="ko-KR" sz="720" b="1" dirty="0">
+                <a:solidFill>
+                  <a:srgbClr val="222222"/>
+                </a:solidFill>
+                <a:latin typeface="Malgun Gothic"/>
+                <a:ea typeface="Malgun Gothic"/>
+              </a:rPr>
+              <a:t>get_medication_side_effect_assessment</a:t>
+            </a:r>
+            <a:br/>
+            <a:r>
+              <a:rPr lang="ko-KR" sz="720" b="1" dirty="0">
+                <a:solidFill>
+                  <a:srgbClr val="222222"/>
+                </a:solidFill>
+                <a:latin typeface="Malgun Gothic"/>
+                <a:ea typeface="Malgun Gothic"/>
+              </a:rPr>
+              <a:t>update_medication_dose_event_status</a:t>
+            </a:r>
+            <a:endParaRPr lang="ko-KR" sz="720" dirty="0">
+              <a:latin typeface="Malgun Gothic"/>
+              <a:ea typeface="Malgun Gothic"/>
+            </a:endParaRPr>
+          </a:p>
+        </p:txBody>
+      </p:sp>
+      <p:cxnSp>
+        <p:nvCxnSpPr>
           <p:cNvPr id="35" name="Arrow 35"/>
           <p:cNvCxnSpPr/>
           <p:nvPr/>
         </p:nvCxnSpPr>
         <p:spPr>
-          <a:xfrm flipV="1">
-            <a:off x="6492240" y="2139696"/>
-            <a:ext cx="594360" cy="18288"/>
+          <a:xfrm>
+            <a:off x="10058400" y="1627632"/>
+            <a:ext cx="411479" cy="429768"/>
           </a:xfrm>
           <a:prstGeom prst="line">
             <a:avLst/>
@@ -1576,9 +1621,9 @@
           <p:nvPr/>
         </p:nvCxnSpPr>
         <p:spPr>
-          <a:xfrm flipV="1">
-            <a:off x="6492240" y="3054096"/>
-            <a:ext cx="594360" cy="18288"/>
+          <a:xfrm>
+            <a:off x="7909560" y="2404872"/>
+            <a:ext cx="1783079" cy="64008"/>
           </a:xfrm>
           <a:prstGeom prst="line">
             <a:avLst/>
@@ -1614,8 +1659,8 @@
         </p:nvCxnSpPr>
         <p:spPr>
           <a:xfrm flipV="1">
-            <a:off x="6492240" y="3968496"/>
-            <a:ext cx="594360" cy="18288"/>
+            <a:off x="7909560" y="2697480"/>
+            <a:ext cx="1783079" cy="1078991"/>
           </a:xfrm>
           <a:prstGeom prst="line">
             <a:avLst/>
@@ -1650,295 +1695,9 @@
           <p:nvPr/>
         </p:nvCxnSpPr>
         <p:spPr>
-          <a:xfrm>
-            <a:off x="8686800" y="3968496"/>
-            <a:ext cx="594360" cy="182880"/>
-          </a:xfrm>
-          <a:prstGeom prst="line">
-            <a:avLst/>
-          </a:prstGeom>
-          <a:ln w="12700">
-            <a:solidFill>
-              <a:srgbClr val="94A3B8"/>
-            </a:solidFill>
-            <a:tailEnd type="none"/>
-            <a:headEnd type="triangle"/>
-          </a:ln>
-        </p:spPr>
-        <p:style>
-          <a:lnRef idx="2">
-            <a:schemeClr val="accent1"/>
-          </a:lnRef>
-          <a:fillRef idx="0">
-            <a:schemeClr val="accent1"/>
-          </a:fillRef>
-          <a:effectRef idx="1">
-            <a:schemeClr val="accent1"/>
-          </a:effectRef>
-          <a:fontRef idx="minor">
-            <a:schemeClr val="tx1"/>
-          </a:fontRef>
-        </p:style>
-      </p:cxnSp>
-      <p:sp>
-        <p:nvSpPr>
-          <p:cNvPr id="39" name="PolicyIntent"/>
-          <p:cNvSpPr/>
-          <p:nvPr/>
-        </p:nvSpPr>
-        <p:spPr>
-          <a:xfrm>
-            <a:off x="7543800" y="4434840"/>
-            <a:ext cx="1783080" cy="411480"/>
-          </a:xfrm>
-          <a:prstGeom prst="roundRect">
-            <a:avLst/>
-          </a:prstGeom>
-          <a:solidFill>
-            <a:srgbClr val="F8FCF9"/>
-          </a:solidFill>
-          <a:ln w="11430">
-            <a:solidFill>
-              <a:srgbClr val="B7D5BF"/>
-            </a:solidFill>
-          </a:ln>
-        </p:spPr>
-        <p:txBody>
-          <a:bodyPr wrap="square" anchor="mid">
-            <a:spAutoFit/>
-          </a:bodyPr>
-          <a:lstStyle/>
-          <a:p>
-            <a:pPr algn="ctr"/>
-            <a:r>
-              <a:rPr lang="ko-KR" sz="760" dirty="0">
-                <a:solidFill>
-                  <a:srgbClr val="222222"/>
-                </a:solidFill>
-                <a:latin typeface="Malgun Gothic"/>
-                <a:ea typeface="Malgun Gothic"/>
-              </a:rPr>
-              <a:t>policy_change_intent</a:t>
-            </a:r>
-            <a:br/>
-            <a:r>
-              <a:rPr lang="ko-KR" sz="760" dirty="0">
-                <a:solidFill>
-                  <a:srgbClr val="222222"/>
-                </a:solidFill>
-                <a:latin typeface="Malgun Gothic"/>
-                <a:ea typeface="Malgun Gothic"/>
-              </a:rPr>
-              <a:t>구조화</a:t>
-            </a:r>
-            <a:endParaRPr lang="ko-KR" sz="760" dirty="0">
-              <a:latin typeface="Malgun Gothic"/>
-              <a:ea typeface="Malgun Gothic"/>
-            </a:endParaRPr>
-          </a:p>
-        </p:txBody>
-      </p:sp>
-      <p:sp>
-        <p:nvSpPr>
-          <p:cNvPr id="40" name="Tools"/>
-          <p:cNvSpPr/>
-          <p:nvPr/>
-        </p:nvSpPr>
-        <p:spPr>
-          <a:xfrm>
-            <a:off x="9692640" y="2057400"/>
-            <a:ext cx="1920240" cy="1234440"/>
-          </a:xfrm>
-          <a:prstGeom prst="roundRect">
-            <a:avLst/>
-          </a:prstGeom>
-          <a:solidFill>
-            <a:srgbClr val="FFF8F8"/>
-          </a:solidFill>
-          <a:ln w="11430">
-            <a:solidFill>
-              <a:srgbClr val="E0A5A5"/>
-            </a:solidFill>
-          </a:ln>
-        </p:spPr>
-        <p:txBody>
-          <a:bodyPr wrap="square" anchor="mid">
-            <a:spAutoFit/>
-          </a:bodyPr>
-          <a:lstStyle/>
-          <a:p>
-            <a:pPr algn="ctr"/>
-            <a:r>
-              <a:rPr lang="ko-KR" sz="760" b="1" dirty="0">
-                <a:solidFill>
-                  <a:srgbClr val="222222"/>
-                </a:solidFill>
-                <a:latin typeface="Malgun Gothic"/>
-                <a:ea typeface="Malgun Gothic"/>
-              </a:rPr>
-              <a:t>Tools</a:t>
-            </a:r>
-            <a:br/>
-            <a:r>
-              <a:rPr lang="ko-KR" sz="760" b="1" dirty="0">
-                <a:solidFill>
-                  <a:srgbClr val="222222"/>
-                </a:solidFill>
-                <a:latin typeface="Malgun Gothic"/>
-                <a:ea typeface="Malgun Gothic"/>
-              </a:rPr>
-              <a:t>apply_notification_policy</a:t>
-            </a:r>
-            <a:br/>
-            <a:r>
-              <a:rPr lang="ko-KR" sz="760" b="1" dirty="0">
-                <a:solidFill>
-                  <a:srgbClr val="222222"/>
-                </a:solidFill>
-                <a:latin typeface="Malgun Gothic"/>
-                <a:ea typeface="Malgun Gothic"/>
-              </a:rPr>
-              <a:t>lookup_side_effect_info</a:t>
-            </a:r>
-            <a:br/>
-            <a:r>
-              <a:rPr lang="ko-KR" sz="760" b="1" dirty="0">
-                <a:solidFill>
-                  <a:srgbClr val="222222"/>
-                </a:solidFill>
-                <a:latin typeface="Malgun Gothic"/>
-                <a:ea typeface="Malgun Gothic"/>
-              </a:rPr>
-              <a:t>mark_dose_taken</a:t>
-            </a:r>
-            <a:endParaRPr lang="ko-KR" sz="760" dirty="0">
-              <a:latin typeface="Malgun Gothic"/>
-              <a:ea typeface="Malgun Gothic"/>
-            </a:endParaRPr>
-          </a:p>
-        </p:txBody>
-      </p:sp>
-      <p:cxnSp>
-        <p:nvCxnSpPr>
-          <p:cNvPr id="41" name="Arrow 41"/>
-          <p:cNvCxnSpPr/>
-          <p:nvPr/>
-        </p:nvCxnSpPr>
-        <p:spPr>
-          <a:xfrm>
-            <a:off x="10058400" y="1627632"/>
-            <a:ext cx="411479" cy="429768"/>
-          </a:xfrm>
-          <a:prstGeom prst="line">
-            <a:avLst/>
-          </a:prstGeom>
-          <a:ln w="12700">
-            <a:solidFill>
-              <a:srgbClr val="94A3B8"/>
-            </a:solidFill>
-            <a:tailEnd type="none"/>
-            <a:headEnd type="triangle"/>
-          </a:ln>
-        </p:spPr>
-        <p:style>
-          <a:lnRef idx="2">
-            <a:schemeClr val="accent1"/>
-          </a:lnRef>
-          <a:fillRef idx="0">
-            <a:schemeClr val="accent1"/>
-          </a:fillRef>
-          <a:effectRef idx="1">
-            <a:schemeClr val="accent1"/>
-          </a:effectRef>
-          <a:fontRef idx="minor">
-            <a:schemeClr val="tx1"/>
-          </a:fontRef>
-        </p:style>
-      </p:cxnSp>
-      <p:cxnSp>
-        <p:nvCxnSpPr>
-          <p:cNvPr id="42" name="Arrow 42"/>
-          <p:cNvCxnSpPr/>
-          <p:nvPr/>
-        </p:nvCxnSpPr>
-        <p:spPr>
-          <a:xfrm>
-            <a:off x="7909560" y="2404872"/>
-            <a:ext cx="1783079" cy="64008"/>
-          </a:xfrm>
-          <a:prstGeom prst="line">
-            <a:avLst/>
-          </a:prstGeom>
-          <a:ln w="12700">
-            <a:solidFill>
-              <a:srgbClr val="94A3B8"/>
-            </a:solidFill>
-            <a:tailEnd type="none"/>
-            <a:headEnd type="triangle"/>
-          </a:ln>
-        </p:spPr>
-        <p:style>
-          <a:lnRef idx="2">
-            <a:schemeClr val="accent1"/>
-          </a:lnRef>
-          <a:fillRef idx="0">
-            <a:schemeClr val="accent1"/>
-          </a:fillRef>
-          <a:effectRef idx="1">
-            <a:schemeClr val="accent1"/>
-          </a:effectRef>
-          <a:fontRef idx="minor">
-            <a:schemeClr val="tx1"/>
-          </a:fontRef>
-        </p:style>
-      </p:cxnSp>
-      <p:cxnSp>
-        <p:nvCxnSpPr>
-          <p:cNvPr id="43" name="Arrow 43"/>
-          <p:cNvCxnSpPr/>
-          <p:nvPr/>
-        </p:nvCxnSpPr>
-        <p:spPr>
-          <a:xfrm flipV="1">
-            <a:off x="7909560" y="2697480"/>
-            <a:ext cx="1783079" cy="621791"/>
-          </a:xfrm>
-          <a:prstGeom prst="line">
-            <a:avLst/>
-          </a:prstGeom>
-          <a:ln w="12700">
-            <a:solidFill>
-              <a:srgbClr val="94A3B8"/>
-            </a:solidFill>
-            <a:tailEnd type="none"/>
-            <a:headEnd type="triangle"/>
-          </a:ln>
-        </p:spPr>
-        <p:style>
-          <a:lnRef idx="2">
-            <a:schemeClr val="accent1"/>
-          </a:lnRef>
-          <a:fillRef idx="0">
-            <a:schemeClr val="accent1"/>
-          </a:fillRef>
-          <a:effectRef idx="1">
-            <a:schemeClr val="accent1"/>
-          </a:effectRef>
-          <a:fontRef idx="minor">
-            <a:schemeClr val="tx1"/>
-          </a:fontRef>
-        </p:style>
-      </p:cxnSp>
-      <p:cxnSp>
-        <p:nvCxnSpPr>
-          <p:cNvPr id="44" name="Arrow 44"/>
-          <p:cNvCxnSpPr/>
-          <p:nvPr/>
-        </p:nvCxnSpPr>
-        <p:spPr>
           <a:xfrm flipV="1">
             <a:off x="10058400" y="3291840"/>
-            <a:ext cx="411479" cy="1124712"/>
+            <a:ext cx="411479" cy="850392"/>
           </a:xfrm>
           <a:prstGeom prst="line">
             <a:avLst/>
@@ -2048,7 +1807,7 @@
                 <a:latin typeface="Malgun Gothic"/>
                 <a:ea typeface="Malgun Gothic"/>
               </a:rPr>
-              <a:t>정책 변경은 후보 생성, 부작용은 PHR 조회, 복약 체크는 system_app action</a:t>
+              <a:t>정책 변경은 승인 후 쓰기, 부작용은 Backend Snapshot 조회, 복약 체크는 Backend action</a:t>
             </a:r>
             <a:endParaRPr lang="ko-KR" sz="1650" dirty="0">
               <a:latin typeface="Malgun Gothic"/>
@@ -2363,13 +2122,13 @@
       </p:sp>
       <p:sp>
         <p:nvSpPr>
-          <p:cNvPr id="22" name="patient_conversation_agent user_reply 단답 처리"/>
-          <p:cNvSpPr/>
-          <p:nvPr/>
-        </p:nvSpPr>
-        <p:spPr>
-          <a:xfrm>
-            <a:off x="502920" y="2880360"/>
+          <p:cNvPr id="22" name="multiturn_chat_agent 자유 대화, 미복용 후속 답변"/>
+          <p:cNvSpPr/>
+          <p:nvPr/>
+        </p:nvSpPr>
+        <p:spPr>
+          <a:xfrm>
+            <a:off x="502920" y="3291840"/>
             <a:ext cx="2514600" cy="530352"/>
           </a:xfrm>
           <a:prstGeom prst="roundRect">
@@ -2399,7 +2158,7 @@
                 <a:latin typeface="Malgun Gothic"/>
                 <a:ea typeface="Malgun Gothic"/>
               </a:rPr>
-              <a:t>patient_conversation_agent</a:t>
+              <a:t>multiturn_chat_agent</a:t>
             </a:r>
             <a:br/>
             <a:r>
@@ -2410,7 +2169,7 @@
                 <a:latin typeface="Malgun Gothic"/>
                 <a:ea typeface="Malgun Gothic"/>
               </a:rPr>
-              <a:t>user_reply 단답 처리</a:t>
+              <a:t>자유 대화, 미복용 후속 답변</a:t>
             </a:r>
             <a:endParaRPr lang="ko-KR" sz="820" dirty="0">
               <a:latin typeface="Malgun Gothic"/>
@@ -2421,65 +2180,7 @@
       </p:sp>
       <p:sp>
         <p:nvSpPr>
-          <p:cNvPr id="23" name="multiturn_chat_agent 자유 대화, 비정책 tool"/>
-          <p:cNvSpPr/>
-          <p:nvPr/>
-        </p:nvSpPr>
-        <p:spPr>
-          <a:xfrm>
-            <a:off x="502920" y="3703320"/>
-            <a:ext cx="2514600" cy="530352"/>
-          </a:xfrm>
-          <a:prstGeom prst="roundRect">
-            <a:avLst/>
-          </a:prstGeom>
-          <a:solidFill>
-            <a:srgbClr val="FFFDF4"/>
-          </a:solidFill>
-          <a:ln w="11430">
-            <a:solidFill>
-              <a:srgbClr val="E7C874"/>
-            </a:solidFill>
-          </a:ln>
-        </p:spPr>
-        <p:txBody>
-          <a:bodyPr wrap="square" anchor="mid">
-            <a:spAutoFit/>
-          </a:bodyPr>
-          <a:lstStyle/>
-          <a:p>
-            <a:pPr algn="ctr"/>
-            <a:r>
-              <a:rPr lang="ko-KR" sz="820" b="1" dirty="0">
-                <a:solidFill>
-                  <a:srgbClr val="222222"/>
-                </a:solidFill>
-                <a:latin typeface="Malgun Gothic"/>
-                <a:ea typeface="Malgun Gothic"/>
-              </a:rPr>
-              <a:t>multiturn_chat_agent</a:t>
-            </a:r>
-            <a:br/>
-            <a:r>
-              <a:rPr lang="ko-KR" sz="820" b="1" dirty="0">
-                <a:solidFill>
-                  <a:srgbClr val="222222"/>
-                </a:solidFill>
-                <a:latin typeface="Malgun Gothic"/>
-                <a:ea typeface="Malgun Gothic"/>
-              </a:rPr>
-              <a:t>자유 대화, 비정책 tool</a:t>
-            </a:r>
-            <a:endParaRPr lang="ko-KR" sz="820" dirty="0">
-              <a:latin typeface="Malgun Gothic"/>
-              <a:ea typeface="Malgun Gothic"/>
-            </a:endParaRPr>
-          </a:p>
-        </p:txBody>
-      </p:sp>
-      <p:sp>
-        <p:nvSpPr>
-          <p:cNvPr id="24" name="side_effect_response_writer PHR 결과 환자 답변화"/>
+          <p:cNvPr id="23" name="side_effect_response_writer 평가 결과 환자 답변화"/>
           <p:cNvSpPr/>
           <p:nvPr/>
         </p:nvSpPr>
@@ -2526,7 +2227,7 @@
                 <a:latin typeface="Malgun Gothic"/>
                 <a:ea typeface="Malgun Gothic"/>
               </a:rPr>
-              <a:t>PHR 결과 환자 답변화</a:t>
+              <a:t>평가 결과 환자 답변화</a:t>
             </a:r>
             <a:endParaRPr lang="ko-KR" sz="820" dirty="0">
               <a:latin typeface="Malgun Gothic"/>
@@ -2537,7 +2238,7 @@
       </p:sp>
       <p:sp>
         <p:nvSpPr>
-          <p:cNvPr id="25" name="apply_notification_policy 정책 변경 후보 생성 확인 알림으로 이어짐"/>
+          <p:cNvPr id="24" name="propose_notification_policy 정책 변경 후보 생성 확인 알림으로 이어짐"/>
           <p:cNvSpPr/>
           <p:nvPr/>
         </p:nvSpPr>
@@ -2573,7 +2274,7 @@
                 <a:latin typeface="Malgun Gothic"/>
                 <a:ea typeface="Malgun Gothic"/>
               </a:rPr>
-              <a:t>apply_notification_policy</a:t>
+              <a:t>propose_notification_policy</a:t>
             </a:r>
             <a:br/>
             <a:r>
@@ -2606,7 +2307,7 @@
       </p:sp>
       <p:sp>
         <p:nvSpPr>
-          <p:cNvPr id="26" name="lookup_side_effect_info PHR 주의사항/부작용 조회"/>
+          <p:cNvPr id="25" name="get_medication_side_effect_assessment 의약품 기준정보/부작용 조회"/>
           <p:cNvSpPr/>
           <p:nvPr/>
         </p:nvSpPr>
@@ -2642,7 +2343,7 @@
                 <a:latin typeface="Malgun Gothic"/>
                 <a:ea typeface="Malgun Gothic"/>
               </a:rPr>
-              <a:t>lookup_side_effect_info</a:t>
+              <a:t>get_medication_side_effect_assessment</a:t>
             </a:r>
             <a:br/>
             <a:r>
@@ -2653,7 +2354,7 @@
                 <a:latin typeface="Malgun Gothic"/>
                 <a:ea typeface="Malgun Gothic"/>
               </a:rPr>
-              <a:t>PHR 주의사항/부작용 조회</a:t>
+              <a:t>의약품 기준정보/부작용 조회</a:t>
             </a:r>
             <a:endParaRPr lang="ko-KR" sz="800" dirty="0">
               <a:latin typeface="Malgun Gothic"/>
@@ -2664,7 +2365,7 @@
       </p:sp>
       <p:sp>
         <p:nvSpPr>
-          <p:cNvPr id="27" name="mark_dose_taken 복약 완료 체크 요청"/>
+          <p:cNvPr id="26" name="update_medication_dose_event_status 복약 완료 체크 요청"/>
           <p:cNvSpPr/>
           <p:nvPr/>
         </p:nvSpPr>
@@ -2700,7 +2401,7 @@
                 <a:latin typeface="Malgun Gothic"/>
                 <a:ea typeface="Malgun Gothic"/>
               </a:rPr>
-              <a:t>mark_dose_taken</a:t>
+              <a:t>update_medication_dose_event_status</a:t>
             </a:r>
             <a:br/>
             <a:r>
@@ -2722,7 +2423,7 @@
       </p:sp>
       <p:sp>
         <p:nvSpPr>
-          <p:cNvPr id="28" name="system_app 정책 확인 알림 DB override 저장"/>
+          <p:cNvPr id="27" name="system_app 정책 확인 알림 DB override 저장"/>
           <p:cNvSpPr/>
           <p:nvPr/>
         </p:nvSpPr>
@@ -2791,7 +2492,7 @@
       </p:sp>
       <p:sp>
         <p:nvSpPr>
-          <p:cNvPr id="29" name="PHR service /phr/side-effects/assess"/>
+          <p:cNvPr id="28" name="Backend Snapshot + AI 기준정보"/>
           <p:cNvSpPr/>
           <p:nvPr/>
         </p:nvSpPr>
@@ -2827,7 +2528,7 @@
                 <a:latin typeface="Malgun Gothic"/>
                 <a:ea typeface="Malgun Gothic"/>
               </a:rPr>
-              <a:t>PHR service</a:t>
+              <a:t>Backend Snapshot</a:t>
             </a:r>
             <a:br/>
             <a:r>
@@ -2838,7 +2539,7 @@
                 <a:latin typeface="Malgun Gothic"/>
                 <a:ea typeface="Malgun Gothic"/>
               </a:rPr>
-              <a:t>/phr/side-effects/assess</a:t>
+              <a:t>+ AI 기준정보</a:t>
             </a:r>
             <a:endParaRPr lang="ko-KR" sz="800" dirty="0">
               <a:latin typeface="Malgun Gothic"/>
@@ -2849,7 +2550,7 @@
       </p:sp>
       <p:sp>
         <p:nvSpPr>
-          <p:cNvPr id="30" name="system_app DoseEvent taken 처리"/>
+          <p:cNvPr id="29" name="system_app DoseEvent taken 처리"/>
           <p:cNvSpPr/>
           <p:nvPr/>
         </p:nvSpPr>
@@ -2905,6 +2606,43 @@
           </a:p>
         </p:txBody>
       </p:sp>
+      <p:cxnSp>
+        <p:nvCxnSpPr>
+          <p:cNvPr id="30" name="Arrow 30"/>
+          <p:cNvCxnSpPr/>
+          <p:nvPr/>
+        </p:nvCxnSpPr>
+        <p:spPr>
+          <a:xfrm>
+            <a:off x="3017520" y="1499616"/>
+            <a:ext cx="1600200" cy="91440"/>
+          </a:xfrm>
+          <a:prstGeom prst="line">
+            <a:avLst/>
+          </a:prstGeom>
+          <a:ln w="12700">
+            <a:solidFill>
+              <a:srgbClr val="94A3B8"/>
+            </a:solidFill>
+            <a:tailEnd type="none"/>
+            <a:headEnd type="triangle"/>
+          </a:ln>
+        </p:spPr>
+        <p:style>
+          <a:lnRef idx="2">
+            <a:schemeClr val="accent1"/>
+          </a:lnRef>
+          <a:fillRef idx="0">
+            <a:schemeClr val="accent1"/>
+          </a:fillRef>
+          <a:effectRef idx="1">
+            <a:schemeClr val="accent1"/>
+          </a:effectRef>
+          <a:fontRef idx="minor">
+            <a:schemeClr val="tx1"/>
+          </a:fontRef>
+        </p:style>
+      </p:cxnSp>
       <p:cxnSp>
         <p:nvCxnSpPr>
           <p:cNvPr id="31" name="Arrow 31"/>
@@ -2913,8 +2651,8 @@
         </p:nvCxnSpPr>
         <p:spPr>
           <a:xfrm>
-            <a:off x="3017520" y="1499616"/>
-            <a:ext cx="1600200" cy="91440"/>
+            <a:off x="3017520" y="2322576"/>
+            <a:ext cx="1600200" cy="731519"/>
           </a:xfrm>
           <a:prstGeom prst="line">
             <a:avLst/>
@@ -2949,9 +2687,9 @@
           <p:nvPr/>
         </p:nvCxnSpPr>
         <p:spPr>
-          <a:xfrm>
-            <a:off x="3017520" y="2322576"/>
-            <a:ext cx="1600200" cy="731519"/>
+          <a:xfrm flipV="1">
+            <a:off x="3017520" y="1591056"/>
+            <a:ext cx="1600200" cy="1554480"/>
           </a:xfrm>
           <a:prstGeom prst="line">
             <a:avLst/>
@@ -2987,8 +2725,8 @@
         </p:nvCxnSpPr>
         <p:spPr>
           <a:xfrm flipV="1">
-            <a:off x="3017520" y="1591056"/>
-            <a:ext cx="1600200" cy="1554480"/>
+            <a:off x="3017520" y="3054096"/>
+            <a:ext cx="1600200" cy="91440"/>
           </a:xfrm>
           <a:prstGeom prst="line">
             <a:avLst/>
@@ -3023,9 +2761,9 @@
           <p:nvPr/>
         </p:nvCxnSpPr>
         <p:spPr>
-          <a:xfrm flipV="1">
-            <a:off x="3017520" y="3054096"/>
-            <a:ext cx="1600200" cy="91440"/>
+          <a:xfrm>
+            <a:off x="3017520" y="3145536"/>
+            <a:ext cx="1600200" cy="1188720"/>
           </a:xfrm>
           <a:prstGeom prst="line">
             <a:avLst/>
@@ -3060,9 +2798,9 @@
           <p:nvPr/>
         </p:nvCxnSpPr>
         <p:spPr>
-          <a:xfrm>
-            <a:off x="3017520" y="3145536"/>
-            <a:ext cx="1600200" cy="1188720"/>
+          <a:xfrm flipV="1">
+            <a:off x="3017520" y="3054096"/>
+            <a:ext cx="1600200" cy="914400"/>
           </a:xfrm>
           <a:prstGeom prst="line">
             <a:avLst/>
@@ -3097,9 +2835,9 @@
           <p:nvPr/>
         </p:nvCxnSpPr>
         <p:spPr>
-          <a:xfrm flipV="1">
-            <a:off x="3017520" y="3054096"/>
-            <a:ext cx="1600200" cy="914400"/>
+          <a:xfrm>
+            <a:off x="3017520" y="3968496"/>
+            <a:ext cx="1600200" cy="365760"/>
           </a:xfrm>
           <a:prstGeom prst="line">
             <a:avLst/>
@@ -3135,8 +2873,8 @@
         </p:nvCxnSpPr>
         <p:spPr>
           <a:xfrm>
-            <a:off x="3017520" y="3968496"/>
-            <a:ext cx="1600200" cy="365760"/>
+            <a:off x="7040880" y="1591056"/>
+            <a:ext cx="1463040" cy="9144"/>
           </a:xfrm>
           <a:prstGeom prst="line">
             <a:avLst/>
@@ -3172,7 +2910,7 @@
         </p:nvCxnSpPr>
         <p:spPr>
           <a:xfrm>
-            <a:off x="7040880" y="1591056"/>
+            <a:off x="7040880" y="3054096"/>
             <a:ext cx="1463040" cy="9144"/>
           </a:xfrm>
           <a:prstGeom prst="line">
@@ -3209,7 +2947,7 @@
         </p:nvCxnSpPr>
         <p:spPr>
           <a:xfrm>
-            <a:off x="7040880" y="3054096"/>
+            <a:off x="7040880" y="4334256"/>
             <a:ext cx="1463040" cy="9144"/>
           </a:xfrm>
           <a:prstGeom prst="line">
@@ -3241,43 +2979,6 @@
       <p:cxnSp>
         <p:nvCxnSpPr>
           <p:cNvPr id="40" name="Arrow 40"/>
-          <p:cNvCxnSpPr/>
-          <p:nvPr/>
-        </p:nvCxnSpPr>
-        <p:spPr>
-          <a:xfrm>
-            <a:off x="7040880" y="4334256"/>
-            <a:ext cx="1463040" cy="9144"/>
-          </a:xfrm>
-          <a:prstGeom prst="line">
-            <a:avLst/>
-          </a:prstGeom>
-          <a:ln w="12700">
-            <a:solidFill>
-              <a:srgbClr val="94A3B8"/>
-            </a:solidFill>
-            <a:tailEnd type="none"/>
-            <a:headEnd type="triangle"/>
-          </a:ln>
-        </p:spPr>
-        <p:style>
-          <a:lnRef idx="2">
-            <a:schemeClr val="accent1"/>
-          </a:lnRef>
-          <a:fillRef idx="0">
-            <a:schemeClr val="accent1"/>
-          </a:fillRef>
-          <a:effectRef idx="1">
-            <a:schemeClr val="accent1"/>
-          </a:effectRef>
-          <a:fontRef idx="minor">
-            <a:schemeClr val="tx1"/>
-          </a:fontRef>
-        </p:style>
-      </p:cxnSp>
-      <p:cxnSp>
-        <p:nvCxnSpPr>
-          <p:cNvPr id="41" name="Arrow 41"/>
           <p:cNvCxnSpPr/>
           <p:nvPr/>
         </p:nvCxnSpPr>
@@ -3659,7 +3360,7 @@
       </p:sp>
       <p:sp>
         <p:nvSpPr>
-          <p:cNvPr id="34" name="apply_notification_policy slot별 정책 후보 리스트"/>
+          <p:cNvPr id="34" name="propose_notification_policy slot별 정책 후보 리스트"/>
           <p:cNvSpPr/>
           <p:nvPr/>
         </p:nvSpPr>
@@ -3695,7 +3396,7 @@
                 <a:latin typeface="Malgun Gothic"/>
                 <a:ea typeface="Malgun Gothic"/>
               </a:rPr>
-              <a:t>apply_notification_policy</a:t>
+              <a:t>propose_notification_policy</a:t>
             </a:r>
             <a:br/>
             <a:r>
@@ -4142,7 +3843,7 @@
                 <a:latin typeface="Malgun Gothic"/>
                 <a:ea typeface="Malgun Gothic"/>
               </a:rPr>
-              <a:t>    {name: apply_notification_policy, arguments: {...}}</a:t>
+              <a:t>    {name: propose_notification_policy, arguments: {...}}</a:t>
             </a:r>
             <a:br/>
             <a:r>

</xml_diff>